<commit_message>
docs: fix PPTX schema-order bug triggering PowerPoint repair dialog
Both decks had <a:tailEnd> placed before <a:prstDash> inside <a:ln>
elements on dashed arrows. OOXML CT_LineProperties requires the
order: fill → prstDash → lnJoin → headEnd → tailEnd. Out-of-order
children caused PowerPoint to flag the file and offer to repair.

Affected: 12 connectors across slides 12, 15, 27, 32 in v2; 1 in v1.
v2 rebuilt with corrected build script (prstDash added before tailEnd).
v1 patched in place via XML element swap.

Verified clean: zero bad-ordered <a:ln> in either file post-fix.

Co-Authored-By: Claude Opus 4.7 (1M context) <noreply@anthropic.com>
</commit_message>
<xml_diff>
--- a/docs_detailed/TizenClaw_First_Principles_v2.pptx
+++ b/docs_detailed/TizenClaw_First_Principles_v2.pptx
@@ -5642,8 +5642,8 @@
             <a:solidFill>
               <a:srgbClr val="2189FF"/>
             </a:solidFill>
+            <a:prstDash val="dash"/>
             <a:tailEnd type="triangle" w="med" h="med"/>
-            <a:prstDash val="dash"/>
           </a:ln>
         </p:spPr>
         <p:style>
@@ -8725,8 +8725,8 @@
             <a:solidFill>
               <a:srgbClr val="1C2540"/>
             </a:solidFill>
+            <a:prstDash val="dash"/>
             <a:tailEnd type="triangle" w="med" h="med"/>
-            <a:prstDash val="dash"/>
           </a:ln>
         </p:spPr>
         <p:style>
@@ -8868,8 +8868,8 @@
             <a:solidFill>
               <a:srgbClr val="1C2540"/>
             </a:solidFill>
+            <a:prstDash val="dash"/>
             <a:tailEnd type="triangle" w="med" h="med"/>
-            <a:prstDash val="dash"/>
           </a:ln>
         </p:spPr>
         <p:style>
@@ -9011,8 +9011,8 @@
             <a:solidFill>
               <a:srgbClr val="1C2540"/>
             </a:solidFill>
+            <a:prstDash val="dash"/>
             <a:tailEnd type="triangle" w="med" h="med"/>
-            <a:prstDash val="dash"/>
           </a:ln>
         </p:spPr>
         <p:style>
@@ -9154,8 +9154,8 @@
             <a:solidFill>
               <a:srgbClr val="1C2540"/>
             </a:solidFill>
+            <a:prstDash val="dash"/>
             <a:tailEnd type="triangle" w="med" h="med"/>
-            <a:prstDash val="dash"/>
           </a:ln>
         </p:spPr>
         <p:style>
@@ -9226,8 +9226,8 @@
             <a:solidFill>
               <a:srgbClr val="1C2540"/>
             </a:solidFill>
+            <a:prstDash val="dash"/>
             <a:tailEnd type="triangle" w="med" h="med"/>
-            <a:prstDash val="dash"/>
           </a:ln>
         </p:spPr>
         <p:style>
@@ -17299,8 +17299,8 @@
             <a:solidFill>
               <a:srgbClr val="B72F2F"/>
             </a:solidFill>
+            <a:prstDash val="dash"/>
             <a:tailEnd type="triangle" w="med" h="med"/>
-            <a:prstDash val="dash"/>
           </a:ln>
         </p:spPr>
         <p:style>
@@ -17336,8 +17336,8 @@
             <a:solidFill>
               <a:srgbClr val="B72F2F"/>
             </a:solidFill>
+            <a:prstDash val="dash"/>
             <a:tailEnd type="triangle" w="med" h="med"/>
-            <a:prstDash val="dash"/>
           </a:ln>
         </p:spPr>
         <p:style>
@@ -17373,8 +17373,8 @@
             <a:solidFill>
               <a:srgbClr val="B72F2F"/>
             </a:solidFill>
+            <a:prstDash val="dash"/>
             <a:tailEnd type="triangle" w="med" h="med"/>
-            <a:prstDash val="dash"/>
           </a:ln>
         </p:spPr>
         <p:style>
@@ -21665,8 +21665,8 @@
             <a:solidFill>
               <a:srgbClr val="2189FF"/>
             </a:solidFill>
+            <a:prstDash val="dash"/>
             <a:tailEnd type="triangle" w="med" h="med"/>
-            <a:prstDash val="dash"/>
           </a:ln>
         </p:spPr>
         <p:style>
@@ -21702,8 +21702,8 @@
             <a:solidFill>
               <a:srgbClr val="2189FF"/>
             </a:solidFill>
+            <a:prstDash val="dash"/>
             <a:tailEnd type="triangle" w="med" h="med"/>
-            <a:prstDash val="dash"/>
           </a:ln>
         </p:spPr>
         <p:style>
@@ -21739,8 +21739,8 @@
             <a:solidFill>
               <a:srgbClr val="2189FF"/>
             </a:solidFill>
+            <a:prstDash val="dash"/>
             <a:tailEnd type="triangle" w="med" h="med"/>
-            <a:prstDash val="dash"/>
           </a:ln>
         </p:spPr>
         <p:style>

</xml_diff>

<commit_message>
docs: fix degenerate-connector PPTX corruption (root cause of repair dialog)
The previous schema-order fix wasn't enough. PowerPoint was still
flagging the file because 31 connectors (1 in v1, 30 in v2) had
cy=0 — degenerate horizontal lines from accent rules under titles
and from horizontal arrows in sequence/flow diagrams.

A connector's <a:ext> with cy=0 (or cx=0) is a zero-extent shape
that PowerPoint's strict parser treats as malformed and offers to
repair, even though python-pptx and many other tools render it fine.

Fixes:
- v1 patched in place (1 connector cy 0 -> 1)
- v2 rebuilt from corrected build script with _ensure_nondegen()
  helper that bumps any zero-axis to 1 EMU before constructing
  the connector. 1 EMU = 1/914400 inch — sub-pixel, no visual change.

Verified: zero degenerate connectors and zero bad-ordered <a:ln>
elements in both files. python-pptx round-trip succeeds.

Co-Authored-By: Claude Opus 4.7 (1M context) <noreply@anthropic.com>
</commit_message>
<xml_diff>
--- a/docs_detailed/TizenClaw_First_Principles_v2.pptx
+++ b/docs_detailed/TizenClaw_First_Principles_v2.pptx
@@ -3489,7 +3489,7 @@
         <p:spPr>
           <a:xfrm>
             <a:off x="576000" y="1008000"/>
-            <a:ext cx="432000" cy="0"/>
+            <a:ext cx="432000" cy="1"/>
           </a:xfrm>
           <a:prstGeom prst="line">
             <a:avLst/>
@@ -4171,7 +4171,7 @@
         <p:spPr>
           <a:xfrm>
             <a:off x="576000" y="1008000"/>
-            <a:ext cx="432000" cy="0"/>
+            <a:ext cx="432000" cy="1"/>
           </a:xfrm>
           <a:prstGeom prst="line">
             <a:avLst/>
@@ -5181,7 +5181,7 @@
         <p:spPr>
           <a:xfrm>
             <a:off x="2154059.5" y="1764000"/>
-            <a:ext cx="0.0" cy="540000"/>
+            <a:ext cx="1.0" cy="540000"/>
           </a:xfrm>
           <a:prstGeom prst="line">
             <a:avLst/>
@@ -5217,7 +5217,7 @@
         <p:spPr>
           <a:xfrm>
             <a:off x="4782059.5" y="1764000"/>
-            <a:ext cx="0.0" cy="540000"/>
+            <a:ext cx="1.0" cy="540000"/>
           </a:xfrm>
           <a:prstGeom prst="line">
             <a:avLst/>
@@ -5253,7 +5253,7 @@
         <p:spPr>
           <a:xfrm>
             <a:off x="7410059.5" y="1764000"/>
-            <a:ext cx="0.0" cy="540000"/>
+            <a:ext cx="1.0" cy="540000"/>
           </a:xfrm>
           <a:prstGeom prst="line">
             <a:avLst/>
@@ -5289,7 +5289,7 @@
         <p:spPr>
           <a:xfrm>
             <a:off x="10038059.5" y="1764000"/>
-            <a:ext cx="0.0" cy="540000"/>
+            <a:ext cx="1.0" cy="540000"/>
           </a:xfrm>
           <a:prstGeom prst="line">
             <a:avLst/>
@@ -5597,7 +5597,7 @@
         <p:spPr>
           <a:xfrm>
             <a:off x="3444029.75" y="4176000"/>
-            <a:ext cx="0.0" cy="252000"/>
+            <a:ext cx="1.0" cy="252000"/>
           </a:xfrm>
           <a:prstGeom prst="line">
             <a:avLst/>
@@ -5633,7 +5633,7 @@
         <p:spPr>
           <a:xfrm>
             <a:off x="8748089.25" y="4176000"/>
-            <a:ext cx="0.0" cy="252000"/>
+            <a:ext cx="1.0" cy="252000"/>
           </a:xfrm>
           <a:prstGeom prst="line">
             <a:avLst/>
@@ -5834,7 +5834,7 @@
         <p:spPr>
           <a:xfrm>
             <a:off x="576000" y="1008000"/>
-            <a:ext cx="432000" cy="0"/>
+            <a:ext cx="432000" cy="1"/>
           </a:xfrm>
           <a:prstGeom prst="line">
             <a:avLst/>
@@ -6999,7 +6999,7 @@
         <p:spPr>
           <a:xfrm>
             <a:off x="576000" y="1008000"/>
-            <a:ext cx="432000" cy="0"/>
+            <a:ext cx="432000" cy="1"/>
           </a:xfrm>
           <a:prstGeom prst="line">
             <a:avLst/>
@@ -7491,7 +7491,7 @@
         <p:spPr>
           <a:xfrm>
             <a:off x="576000" y="1008000"/>
-            <a:ext cx="432000" cy="0"/>
+            <a:ext cx="432000" cy="1"/>
           </a:xfrm>
           <a:prstGeom prst="line">
             <a:avLst/>
@@ -7650,7 +7650,7 @@
         <p:spPr>
           <a:xfrm>
             <a:off x="1364579.9285714286" y="1548000"/>
-            <a:ext cx="0.0" cy="4572000"/>
+            <a:ext cx="1.0" cy="4572000"/>
           </a:xfrm>
           <a:prstGeom prst="line">
             <a:avLst/>
@@ -7739,7 +7739,7 @@
         <p:spPr>
           <a:xfrm>
             <a:off x="2941739.785714286" y="1548000"/>
-            <a:ext cx="0.0" cy="4572000"/>
+            <a:ext cx="1.0" cy="4572000"/>
           </a:xfrm>
           <a:prstGeom prst="line">
             <a:avLst/>
@@ -7828,7 +7828,7 @@
         <p:spPr>
           <a:xfrm>
             <a:off x="4518899.642857143" y="1548000"/>
-            <a:ext cx="0.0" cy="4572000"/>
+            <a:ext cx="1.0" cy="4572000"/>
           </a:xfrm>
           <a:prstGeom prst="line">
             <a:avLst/>
@@ -7917,7 +7917,7 @@
         <p:spPr>
           <a:xfrm>
             <a:off x="6096059.499999999" y="1548000"/>
-            <a:ext cx="0.0" cy="4572000"/>
+            <a:ext cx="1.0" cy="4572000"/>
           </a:xfrm>
           <a:prstGeom prst="line">
             <a:avLst/>
@@ -8006,7 +8006,7 @@
         <p:spPr>
           <a:xfrm>
             <a:off x="7673219.357142856" y="1548000"/>
-            <a:ext cx="0.0" cy="4572000"/>
+            <a:ext cx="1.0" cy="4572000"/>
           </a:xfrm>
           <a:prstGeom prst="line">
             <a:avLst/>
@@ -8095,7 +8095,7 @@
         <p:spPr>
           <a:xfrm>
             <a:off x="9250379.214285715" y="1548000"/>
-            <a:ext cx="0.0" cy="4572000"/>
+            <a:ext cx="1.0" cy="4572000"/>
           </a:xfrm>
           <a:prstGeom prst="line">
             <a:avLst/>
@@ -8184,7 +8184,7 @@
         <p:spPr>
           <a:xfrm>
             <a:off x="10827539.07142857" y="1548000"/>
-            <a:ext cx="0.0" cy="4572000"/>
+            <a:ext cx="1.0" cy="4572000"/>
           </a:xfrm>
           <a:prstGeom prst="line">
             <a:avLst/>
@@ -8219,7 +8219,7 @@
         <p:spPr>
           <a:xfrm>
             <a:off x="1364579.9285714286" y="1656000"/>
-            <a:ext cx="1577159.8571428573" cy="0"/>
+            <a:ext cx="1577159.8571428573" cy="1"/>
           </a:xfrm>
           <a:prstGeom prst="line">
             <a:avLst/>
@@ -8290,7 +8290,7 @@
         <p:spPr>
           <a:xfrm>
             <a:off x="2941739.785714286" y="1980000"/>
-            <a:ext cx="1577159.8571428568" cy="0"/>
+            <a:ext cx="1577159.8571428568" cy="1"/>
           </a:xfrm>
           <a:prstGeom prst="line">
             <a:avLst/>
@@ -8361,7 +8361,7 @@
         <p:spPr>
           <a:xfrm>
             <a:off x="4518899.642857143" y="2304000"/>
-            <a:ext cx="1577159.8571428563" cy="0"/>
+            <a:ext cx="1577159.8571428563" cy="1"/>
           </a:xfrm>
           <a:prstGeom prst="line">
             <a:avLst/>
@@ -8432,7 +8432,7 @@
         <p:spPr>
           <a:xfrm>
             <a:off x="4518899.642857143" y="2628000"/>
-            <a:ext cx="1577159.8571428563" cy="0"/>
+            <a:ext cx="1577159.8571428563" cy="1"/>
           </a:xfrm>
           <a:prstGeom prst="line">
             <a:avLst/>
@@ -8503,7 +8503,7 @@
         <p:spPr>
           <a:xfrm>
             <a:off x="4518899.642857143" y="2952000"/>
-            <a:ext cx="3154319.7142857136" cy="0"/>
+            <a:ext cx="3154319.7142857136" cy="1"/>
           </a:xfrm>
           <a:prstGeom prst="line">
             <a:avLst/>
@@ -8574,7 +8574,7 @@
         <p:spPr>
           <a:xfrm>
             <a:off x="4572899.642857143" y="3276000"/>
-            <a:ext cx="0.0" cy="162000"/>
+            <a:ext cx="1.0" cy="162000"/>
           </a:xfrm>
           <a:prstGeom prst="line">
             <a:avLst/>
@@ -8645,7 +8645,7 @@
         <p:spPr>
           <a:xfrm>
             <a:off x="4518899.642857143" y="3600000"/>
-            <a:ext cx="4731479.571428572" cy="0"/>
+            <a:ext cx="4731479.571428572" cy="1"/>
           </a:xfrm>
           <a:prstGeom prst="line">
             <a:avLst/>
@@ -8716,7 +8716,7 @@
         <p:spPr>
           <a:xfrm flipH="1">
             <a:off x="4518899.642857143" y="3924000"/>
-            <a:ext cx="4731479.571428572" cy="0"/>
+            <a:ext cx="4731479.571428572" cy="1"/>
           </a:xfrm>
           <a:prstGeom prst="line">
             <a:avLst/>
@@ -8788,7 +8788,7 @@
         <p:spPr>
           <a:xfrm>
             <a:off x="4518899.642857143" y="4248000"/>
-            <a:ext cx="6308639.428571428" cy="0"/>
+            <a:ext cx="6308639.428571428" cy="1"/>
           </a:xfrm>
           <a:prstGeom prst="line">
             <a:avLst/>
@@ -8859,7 +8859,7 @@
         <p:spPr>
           <a:xfrm flipH="1">
             <a:off x="4518899.642857143" y="4572000"/>
-            <a:ext cx="6308639.428571428" cy="0"/>
+            <a:ext cx="6308639.428571428" cy="1"/>
           </a:xfrm>
           <a:prstGeom prst="line">
             <a:avLst/>
@@ -8931,7 +8931,7 @@
         <p:spPr>
           <a:xfrm>
             <a:off x="4518899.642857143" y="4896000"/>
-            <a:ext cx="4731479.571428572" cy="0"/>
+            <a:ext cx="4731479.571428572" cy="1"/>
           </a:xfrm>
           <a:prstGeom prst="line">
             <a:avLst/>
@@ -9002,7 +9002,7 @@
         <p:spPr>
           <a:xfrm flipH="1">
             <a:off x="4518899.642857143" y="5219999"/>
-            <a:ext cx="4731479.571428572" cy="0"/>
+            <a:ext cx="4731479.571428572" cy="1"/>
           </a:xfrm>
           <a:prstGeom prst="line">
             <a:avLst/>
@@ -9074,7 +9074,7 @@
         <p:spPr>
           <a:xfrm>
             <a:off x="4518899.642857143" y="5544000"/>
-            <a:ext cx="1577159.8571428563" cy="0"/>
+            <a:ext cx="1577159.8571428563" cy="1"/>
           </a:xfrm>
           <a:prstGeom prst="line">
             <a:avLst/>
@@ -9145,7 +9145,7 @@
         <p:spPr>
           <a:xfrm flipH="1">
             <a:off x="2941739.785714286" y="5868000"/>
-            <a:ext cx="1577159.8571428568" cy="0"/>
+            <a:ext cx="1577159.8571428568" cy="1"/>
           </a:xfrm>
           <a:prstGeom prst="line">
             <a:avLst/>
@@ -9217,7 +9217,7 @@
         <p:spPr>
           <a:xfrm flipH="1">
             <a:off x="1364579.9285714286" y="6192000"/>
-            <a:ext cx="1577159.8571428573" cy="0"/>
+            <a:ext cx="1577159.8571428573" cy="1"/>
           </a:xfrm>
           <a:prstGeom prst="line">
             <a:avLst/>
@@ -9693,7 +9693,7 @@
         <p:spPr>
           <a:xfrm>
             <a:off x="576000" y="1008000"/>
-            <a:ext cx="432000" cy="0"/>
+            <a:ext cx="432000" cy="1"/>
           </a:xfrm>
           <a:prstGeom prst="line">
             <a:avLst/>
@@ -10787,7 +10787,7 @@
         <p:spPr>
           <a:xfrm>
             <a:off x="576000" y="1008000"/>
-            <a:ext cx="432000" cy="0"/>
+            <a:ext cx="432000" cy="1"/>
           </a:xfrm>
           <a:prstGeom prst="line">
             <a:avLst/>
@@ -11469,7 +11469,7 @@
         <p:spPr>
           <a:xfrm>
             <a:off x="576000" y="1008000"/>
-            <a:ext cx="432000" cy="0"/>
+            <a:ext cx="432000" cy="1"/>
           </a:xfrm>
           <a:prstGeom prst="line">
             <a:avLst/>
@@ -11986,7 +11986,7 @@
         <p:spPr>
           <a:xfrm>
             <a:off x="576000" y="1008000"/>
-            <a:ext cx="432000" cy="0"/>
+            <a:ext cx="432000" cy="1"/>
           </a:xfrm>
           <a:prstGeom prst="line">
             <a:avLst/>
@@ -13365,7 +13365,7 @@
         <p:spPr>
           <a:xfrm>
             <a:off x="576000" y="1008000"/>
-            <a:ext cx="432000" cy="0"/>
+            <a:ext cx="432000" cy="1"/>
           </a:xfrm>
           <a:prstGeom prst="line">
             <a:avLst/>
@@ -14012,7 +14012,7 @@
         <p:spPr>
           <a:xfrm>
             <a:off x="576000" y="1008000"/>
-            <a:ext cx="432000" cy="0"/>
+            <a:ext cx="432000" cy="1"/>
           </a:xfrm>
           <a:prstGeom prst="line">
             <a:avLst/>
@@ -14678,7 +14678,7 @@
         <p:spPr>
           <a:xfrm>
             <a:off x="576000" y="1008000"/>
-            <a:ext cx="432000" cy="0"/>
+            <a:ext cx="432000" cy="1"/>
           </a:xfrm>
           <a:prstGeom prst="line">
             <a:avLst/>
@@ -15991,7 +15991,7 @@
         <p:spPr>
           <a:xfrm>
             <a:off x="576000" y="1008000"/>
-            <a:ext cx="432000" cy="0"/>
+            <a:ext cx="432000" cy="1"/>
           </a:xfrm>
           <a:prstGeom prst="line">
             <a:avLst/>
@@ -16638,7 +16638,7 @@
         <p:spPr>
           <a:xfrm>
             <a:off x="576000" y="1008000"/>
-            <a:ext cx="432000" cy="0"/>
+            <a:ext cx="432000" cy="1"/>
           </a:xfrm>
           <a:prstGeom prst="line">
             <a:avLst/>
@@ -17081,7 +17081,7 @@
         <p:spPr>
           <a:xfrm>
             <a:off x="2556000" y="3276000.0"/>
-            <a:ext cx="251999" cy="0.0"/>
+            <a:ext cx="251999" cy="1.0"/>
           </a:xfrm>
           <a:prstGeom prst="line">
             <a:avLst/>
@@ -17117,7 +17117,7 @@
         <p:spPr>
           <a:xfrm>
             <a:off x="4715999" y="3276000.0"/>
-            <a:ext cx="251999" cy="0.0"/>
+            <a:ext cx="251999" cy="1.0"/>
           </a:xfrm>
           <a:prstGeom prst="line">
             <a:avLst/>
@@ -17153,7 +17153,7 @@
         <p:spPr>
           <a:xfrm>
             <a:off x="6875998" y="3276000.0"/>
-            <a:ext cx="251999" cy="0.0"/>
+            <a:ext cx="251999" cy="1.0"/>
           </a:xfrm>
           <a:prstGeom prst="line">
             <a:avLst/>
@@ -17189,7 +17189,7 @@
         <p:spPr>
           <a:xfrm>
             <a:off x="9035997" y="3276000.0"/>
-            <a:ext cx="251999" cy="0.0"/>
+            <a:ext cx="251999" cy="1.0"/>
           </a:xfrm>
           <a:prstGeom prst="line">
             <a:avLst/>
@@ -17290,7 +17290,7 @@
         <p:spPr>
           <a:xfrm>
             <a:off x="3761999.0" y="3852000"/>
-            <a:ext cx="0.0" cy="684000"/>
+            <a:ext cx="1.0" cy="684000"/>
           </a:xfrm>
           <a:prstGeom prst="line">
             <a:avLst/>
@@ -17327,7 +17327,7 @@
         <p:spPr>
           <a:xfrm>
             <a:off x="5921998.0" y="3852000"/>
-            <a:ext cx="0.0" cy="684000"/>
+            <a:ext cx="1.0" cy="684000"/>
           </a:xfrm>
           <a:prstGeom prst="line">
             <a:avLst/>
@@ -17364,7 +17364,7 @@
         <p:spPr>
           <a:xfrm>
             <a:off x="8081997.0" y="3852000"/>
-            <a:ext cx="0.0" cy="684000"/>
+            <a:ext cx="1.0" cy="684000"/>
           </a:xfrm>
           <a:prstGeom prst="line">
             <a:avLst/>
@@ -17565,7 +17565,7 @@
         <p:spPr>
           <a:xfrm>
             <a:off x="576000" y="1008000"/>
-            <a:ext cx="432000" cy="0"/>
+            <a:ext cx="432000" cy="1"/>
           </a:xfrm>
           <a:prstGeom prst="line">
             <a:avLst/>
@@ -18695,7 +18695,7 @@
         <p:spPr>
           <a:xfrm>
             <a:off x="576000" y="1008000"/>
-            <a:ext cx="432000" cy="0"/>
+            <a:ext cx="432000" cy="1"/>
           </a:xfrm>
           <a:prstGeom prst="line">
             <a:avLst/>
@@ -20248,7 +20248,7 @@
         <p:spPr>
           <a:xfrm>
             <a:off x="576000" y="1008000"/>
-            <a:ext cx="432000" cy="0"/>
+            <a:ext cx="432000" cy="1"/>
           </a:xfrm>
           <a:prstGeom prst="line">
             <a:avLst/>
@@ -20895,7 +20895,7 @@
         <p:spPr>
           <a:xfrm>
             <a:off x="576000" y="1008000"/>
-            <a:ext cx="432000" cy="0"/>
+            <a:ext cx="432000" cy="1"/>
           </a:xfrm>
           <a:prstGeom prst="line">
             <a:avLst/>
@@ -21693,7 +21693,7 @@
         <p:spPr>
           <a:xfrm>
             <a:off x="6096059.5" y="2052000"/>
-            <a:ext cx="0.0" cy="1764000"/>
+            <a:ext cx="1.0" cy="1764000"/>
           </a:xfrm>
           <a:prstGeom prst="line">
             <a:avLst/>
@@ -21953,7 +21953,7 @@
         <p:spPr>
           <a:xfrm>
             <a:off x="576000" y="1008000"/>
-            <a:ext cx="432000" cy="0"/>
+            <a:ext cx="432000" cy="1"/>
           </a:xfrm>
           <a:prstGeom prst="line">
             <a:avLst/>
@@ -22360,7 +22360,7 @@
         <p:spPr>
           <a:xfrm>
             <a:off x="576000" y="1008000"/>
-            <a:ext cx="432000" cy="0"/>
+            <a:ext cx="432000" cy="1"/>
           </a:xfrm>
           <a:prstGeom prst="line">
             <a:avLst/>
@@ -23042,7 +23042,7 @@
         <p:spPr>
           <a:xfrm>
             <a:off x="576000" y="1008000"/>
-            <a:ext cx="432000" cy="0"/>
+            <a:ext cx="432000" cy="1"/>
           </a:xfrm>
           <a:prstGeom prst="line">
             <a:avLst/>
@@ -23449,7 +23449,7 @@
         <p:spPr>
           <a:xfrm>
             <a:off x="576000" y="1008000"/>
-            <a:ext cx="432000" cy="0"/>
+            <a:ext cx="432000" cy="1"/>
           </a:xfrm>
           <a:prstGeom prst="line">
             <a:avLst/>
@@ -24466,7 +24466,7 @@
         <p:spPr>
           <a:xfrm>
             <a:off x="576000" y="1008000"/>
-            <a:ext cx="432000" cy="0"/>
+            <a:ext cx="432000" cy="1"/>
           </a:xfrm>
           <a:prstGeom prst="line">
             <a:avLst/>
@@ -25113,7 +25113,7 @@
         <p:spPr>
           <a:xfrm>
             <a:off x="576000" y="1008000"/>
-            <a:ext cx="432000" cy="0"/>
+            <a:ext cx="432000" cy="1"/>
           </a:xfrm>
           <a:prstGeom prst="line">
             <a:avLst/>
@@ -25495,7 +25495,7 @@
         <p:spPr>
           <a:xfrm>
             <a:off x="576000" y="1008000"/>
-            <a:ext cx="432000" cy="0"/>
+            <a:ext cx="432000" cy="1"/>
           </a:xfrm>
           <a:prstGeom prst="line">
             <a:avLst/>
@@ -25952,7 +25952,7 @@
         <p:spPr>
           <a:xfrm>
             <a:off x="576000" y="1008000"/>
-            <a:ext cx="432000" cy="0"/>
+            <a:ext cx="432000" cy="1"/>
           </a:xfrm>
           <a:prstGeom prst="line">
             <a:avLst/>
@@ -26659,7 +26659,7 @@
         <p:spPr>
           <a:xfrm>
             <a:off x="576000" y="1008000"/>
-            <a:ext cx="432000" cy="0"/>
+            <a:ext cx="432000" cy="1"/>
           </a:xfrm>
           <a:prstGeom prst="line">
             <a:avLst/>
@@ -27341,7 +27341,7 @@
         <p:spPr>
           <a:xfrm>
             <a:off x="576000" y="1008000"/>
-            <a:ext cx="432000" cy="0"/>
+            <a:ext cx="432000" cy="1"/>
           </a:xfrm>
           <a:prstGeom prst="line">
             <a:avLst/>
@@ -28007,7 +28007,7 @@
         <p:spPr>
           <a:xfrm>
             <a:off x="576000" y="1008000"/>
-            <a:ext cx="432000" cy="0"/>
+            <a:ext cx="432000" cy="1"/>
           </a:xfrm>
           <a:prstGeom prst="line">
             <a:avLst/>
@@ -28414,7 +28414,7 @@
         <p:spPr>
           <a:xfrm>
             <a:off x="576000" y="1008000"/>
-            <a:ext cx="432000" cy="0"/>
+            <a:ext cx="432000" cy="1"/>
           </a:xfrm>
           <a:prstGeom prst="line">
             <a:avLst/>

</xml_diff>